<commit_message>
feat: add direction heatmap to ventcov sensitivity PPTX slide and output folder
</commit_message>
<xml_diff>
--- a/code/analysis_bundle/output/figures/sensitivity_ventcov/etco2_sensitivity_5model_forest.pptx
+++ b/code/analysis_bundle/output/figures/sensitivity_ventcov/etco2_sensitivity_5model_forest.pptx
@@ -6,6 +6,7 @@
   </p:sldMasterIdLst>
   <p:sldIdLst>
     <p:sldId id="256" r:id="rId8"/>
+    <p:sldId id="257" r:id="rId9"/>
   </p:sldIdLst>
   <p:sldSz cx="12191695" cy="6858000" type="screen4x3"/>
   <p:notesSz cx="6858000" cy="9144000"/>
@@ -6283,6 +6284,2019 @@
 </p:sld>
 </file>
 
+<file path=ppt/slides/slide2.xml><?xml version="1.0" encoding="utf-8"?>
+<p:sld xmlns:a="http://schemas.openxmlformats.org/drawingml/2006/main" xmlns:r="http://schemas.openxmlformats.org/officeDocument/2006/relationships" xmlns:p="http://schemas.openxmlformats.org/presentationml/2006/main">
+  <p:cSld>
+    <p:spTree>
+      <p:nvGrpSpPr>
+        <p:cNvPr id="1" name=""/>
+        <p:cNvGrpSpPr/>
+        <p:nvPr/>
+      </p:nvGrpSpPr>
+      <p:grpSpPr>
+        <a:xfrm>
+          <a:off x="0" y="0"/>
+          <a:ext cx="0" cy="0"/>
+          <a:chOff x="0" y="0"/>
+          <a:chExt cx="0" cy="0"/>
+        </a:xfrm>
+      </p:grpSpPr>
+      <p:grpSp xmlns:pic="http://schemas.openxmlformats.org/drawingml/2006/picture">
+        <p:nvGrpSpPr>
+          <p:cNvPr id="2" name=""/>
+          <p:cNvGrpSpPr/>
+          <p:nvPr/>
+        </p:nvGrpSpPr>
+        <p:grpSpPr>
+          <a:xfrm>
+            <a:off x="2666848" y="1143000"/>
+            <a:ext cx="6858000" cy="4572000"/>
+            <a:chOff x="2666848" y="1143000"/>
+            <a:chExt cx="6858000" cy="4572000"/>
+          </a:xfrm>
+        </p:grpSpPr>
+        <p:sp>
+          <p:nvSpPr>
+            <p:cNvPr id="3" name="rc3"/>
+            <p:cNvSpPr/>
+            <p:nvPr/>
+          </p:nvSpPr>
+          <p:spPr>
+            <a:xfrm>
+              <a:off x="2666847" y="1143000"/>
+              <a:ext cx="6858000" cy="4572000"/>
+            </a:xfrm>
+            <a:prstGeom prst="rect">
+              <a:avLst/>
+            </a:prstGeom>
+            <a:solidFill>
+              <a:srgbClr val="FFFFFF">
+                <a:alpha val="100000"/>
+              </a:srgbClr>
+            </a:solidFill>
+            <a:ln w="9525" cap="rnd">
+              <a:solidFill>
+                <a:srgbClr val="FFFFFF">
+                  <a:alpha val="100000"/>
+                </a:srgbClr>
+              </a:solidFill>
+              <a:prstDash val="solid"/>
+              <a:round/>
+            </a:ln>
+          </p:spPr>
+          <p:txBody>
+            <a:bodyPr/>
+            <a:lstStyle/>
+            <a:p/>
+          </p:txBody>
+        </p:sp>
+        <p:sp>
+          <p:nvSpPr>
+            <p:cNvPr id="4" name="rc4"/>
+            <p:cNvSpPr/>
+            <p:nvPr/>
+          </p:nvSpPr>
+          <p:spPr>
+            <a:xfrm>
+              <a:off x="2666847" y="1143000"/>
+              <a:ext cx="6858000" cy="4572000"/>
+            </a:xfrm>
+            <a:prstGeom prst="rect">
+              <a:avLst/>
+            </a:prstGeom>
+            <a:solidFill>
+              <a:srgbClr val="FFFFFF">
+                <a:alpha val="100000"/>
+              </a:srgbClr>
+            </a:solidFill>
+          </p:spPr>
+          <p:txBody>
+            <a:bodyPr/>
+            <a:lstStyle/>
+            <a:p/>
+          </p:txBody>
+        </p:sp>
+        <p:sp>
+          <p:nvSpPr>
+            <p:cNvPr id="5" name="rc5"/>
+            <p:cNvSpPr/>
+            <p:nvPr/>
+          </p:nvSpPr>
+          <p:spPr>
+            <a:xfrm>
+              <a:off x="4480668" y="1212589"/>
+              <a:ext cx="3754714" cy="4275365"/>
+            </a:xfrm>
+            <a:prstGeom prst="rect">
+              <a:avLst/>
+            </a:prstGeom>
+            <a:solidFill>
+              <a:srgbClr val="FFFFFF">
+                <a:alpha val="100000"/>
+              </a:srgbClr>
+            </a:solidFill>
+          </p:spPr>
+          <p:txBody>
+            <a:bodyPr/>
+            <a:lstStyle/>
+            <a:p/>
+          </p:txBody>
+        </p:sp>
+        <p:sp>
+          <p:nvSpPr>
+            <p:cNvPr id="6" name="rc6"/>
+            <p:cNvSpPr/>
+            <p:nvPr/>
+          </p:nvSpPr>
+          <p:spPr>
+            <a:xfrm>
+              <a:off x="4598003" y="1294807"/>
+              <a:ext cx="1173348" cy="822185"/>
+            </a:xfrm>
+            <a:prstGeom prst="rect">
+              <a:avLst/>
+            </a:prstGeom>
+            <a:solidFill>
+              <a:srgbClr val="4F86C6">
+                <a:alpha val="100000"/>
+              </a:srgbClr>
+            </a:solidFill>
+            <a:ln w="24391" cap="flat">
+              <a:solidFill>
+                <a:srgbClr val="FFFFFF">
+                  <a:alpha val="100000"/>
+                </a:srgbClr>
+              </a:solidFill>
+              <a:prstDash val="solid"/>
+              <a:miter/>
+            </a:ln>
+          </p:spPr>
+          <p:txBody>
+            <a:bodyPr/>
+            <a:lstStyle/>
+            <a:p/>
+          </p:txBody>
+        </p:sp>
+        <p:sp>
+          <p:nvSpPr>
+            <p:cNvPr id="7" name="rc7"/>
+            <p:cNvSpPr/>
+            <p:nvPr/>
+          </p:nvSpPr>
+          <p:spPr>
+            <a:xfrm>
+              <a:off x="5771351" y="1294807"/>
+              <a:ext cx="1173348" cy="822185"/>
+            </a:xfrm>
+            <a:prstGeom prst="rect">
+              <a:avLst/>
+            </a:prstGeom>
+            <a:solidFill>
+              <a:srgbClr val="4F86C6">
+                <a:alpha val="100000"/>
+              </a:srgbClr>
+            </a:solidFill>
+            <a:ln w="24391" cap="flat">
+              <a:solidFill>
+                <a:srgbClr val="FFFFFF">
+                  <a:alpha val="100000"/>
+                </a:srgbClr>
+              </a:solidFill>
+              <a:prstDash val="solid"/>
+              <a:miter/>
+            </a:ln>
+          </p:spPr>
+          <p:txBody>
+            <a:bodyPr/>
+            <a:lstStyle/>
+            <a:p/>
+          </p:txBody>
+        </p:sp>
+        <p:sp>
+          <p:nvSpPr>
+            <p:cNvPr id="8" name="rc8"/>
+            <p:cNvSpPr/>
+            <p:nvPr/>
+          </p:nvSpPr>
+          <p:spPr>
+            <a:xfrm>
+              <a:off x="6944699" y="1294807"/>
+              <a:ext cx="1173348" cy="822185"/>
+            </a:xfrm>
+            <a:prstGeom prst="rect">
+              <a:avLst/>
+            </a:prstGeom>
+            <a:solidFill>
+              <a:srgbClr val="4F86C6">
+                <a:alpha val="100000"/>
+              </a:srgbClr>
+            </a:solidFill>
+            <a:ln w="24391" cap="flat">
+              <a:solidFill>
+                <a:srgbClr val="FFFFFF">
+                  <a:alpha val="100000"/>
+                </a:srgbClr>
+              </a:solidFill>
+              <a:prstDash val="solid"/>
+              <a:miter/>
+            </a:ln>
+          </p:spPr>
+          <p:txBody>
+            <a:bodyPr/>
+            <a:lstStyle/>
+            <a:p/>
+          </p:txBody>
+        </p:sp>
+        <p:sp>
+          <p:nvSpPr>
+            <p:cNvPr id="9" name="rc9"/>
+            <p:cNvSpPr/>
+            <p:nvPr/>
+          </p:nvSpPr>
+          <p:spPr>
+            <a:xfrm>
+              <a:off x="4598003" y="2116993"/>
+              <a:ext cx="1173348" cy="822185"/>
+            </a:xfrm>
+            <a:prstGeom prst="rect">
+              <a:avLst/>
+            </a:prstGeom>
+            <a:solidFill>
+              <a:srgbClr val="4F86C6">
+                <a:alpha val="100000"/>
+              </a:srgbClr>
+            </a:solidFill>
+            <a:ln w="24391" cap="flat">
+              <a:solidFill>
+                <a:srgbClr val="FFFFFF">
+                  <a:alpha val="100000"/>
+                </a:srgbClr>
+              </a:solidFill>
+              <a:prstDash val="solid"/>
+              <a:miter/>
+            </a:ln>
+          </p:spPr>
+          <p:txBody>
+            <a:bodyPr/>
+            <a:lstStyle/>
+            <a:p/>
+          </p:txBody>
+        </p:sp>
+        <p:sp>
+          <p:nvSpPr>
+            <p:cNvPr id="10" name="rc10"/>
+            <p:cNvSpPr/>
+            <p:nvPr/>
+          </p:nvSpPr>
+          <p:spPr>
+            <a:xfrm>
+              <a:off x="5771351" y="2116993"/>
+              <a:ext cx="1173348" cy="822185"/>
+            </a:xfrm>
+            <a:prstGeom prst="rect">
+              <a:avLst/>
+            </a:prstGeom>
+            <a:solidFill>
+              <a:srgbClr val="4F86C6">
+                <a:alpha val="100000"/>
+              </a:srgbClr>
+            </a:solidFill>
+            <a:ln w="24391" cap="flat">
+              <a:solidFill>
+                <a:srgbClr val="FFFFFF">
+                  <a:alpha val="100000"/>
+                </a:srgbClr>
+              </a:solidFill>
+              <a:prstDash val="solid"/>
+              <a:miter/>
+            </a:ln>
+          </p:spPr>
+          <p:txBody>
+            <a:bodyPr/>
+            <a:lstStyle/>
+            <a:p/>
+          </p:txBody>
+        </p:sp>
+        <p:sp>
+          <p:nvSpPr>
+            <p:cNvPr id="11" name="rc11"/>
+            <p:cNvSpPr/>
+            <p:nvPr/>
+          </p:nvSpPr>
+          <p:spPr>
+            <a:xfrm>
+              <a:off x="6944699" y="2116993"/>
+              <a:ext cx="1173348" cy="822185"/>
+            </a:xfrm>
+            <a:prstGeom prst="rect">
+              <a:avLst/>
+            </a:prstGeom>
+            <a:solidFill>
+              <a:srgbClr val="4F86C6">
+                <a:alpha val="100000"/>
+              </a:srgbClr>
+            </a:solidFill>
+            <a:ln w="24391" cap="flat">
+              <a:solidFill>
+                <a:srgbClr val="FFFFFF">
+                  <a:alpha val="100000"/>
+                </a:srgbClr>
+              </a:solidFill>
+              <a:prstDash val="solid"/>
+              <a:miter/>
+            </a:ln>
+          </p:spPr>
+          <p:txBody>
+            <a:bodyPr/>
+            <a:lstStyle/>
+            <a:p/>
+          </p:txBody>
+        </p:sp>
+        <p:sp>
+          <p:nvSpPr>
+            <p:cNvPr id="12" name="rc12"/>
+            <p:cNvSpPr/>
+            <p:nvPr/>
+          </p:nvSpPr>
+          <p:spPr>
+            <a:xfrm>
+              <a:off x="4598003" y="2939178"/>
+              <a:ext cx="1173348" cy="822185"/>
+            </a:xfrm>
+            <a:prstGeom prst="rect">
+              <a:avLst/>
+            </a:prstGeom>
+            <a:solidFill>
+              <a:srgbClr val="4F86C6">
+                <a:alpha val="100000"/>
+              </a:srgbClr>
+            </a:solidFill>
+            <a:ln w="24391" cap="flat">
+              <a:solidFill>
+                <a:srgbClr val="FFFFFF">
+                  <a:alpha val="100000"/>
+                </a:srgbClr>
+              </a:solidFill>
+              <a:prstDash val="solid"/>
+              <a:miter/>
+            </a:ln>
+          </p:spPr>
+          <p:txBody>
+            <a:bodyPr/>
+            <a:lstStyle/>
+            <a:p/>
+          </p:txBody>
+        </p:sp>
+        <p:sp>
+          <p:nvSpPr>
+            <p:cNvPr id="13" name="rc13"/>
+            <p:cNvSpPr/>
+            <p:nvPr/>
+          </p:nvSpPr>
+          <p:spPr>
+            <a:xfrm>
+              <a:off x="5771351" y="2939178"/>
+              <a:ext cx="1173348" cy="822185"/>
+            </a:xfrm>
+            <a:prstGeom prst="rect">
+              <a:avLst/>
+            </a:prstGeom>
+            <a:solidFill>
+              <a:srgbClr val="4F86C6">
+                <a:alpha val="100000"/>
+              </a:srgbClr>
+            </a:solidFill>
+            <a:ln w="24391" cap="flat">
+              <a:solidFill>
+                <a:srgbClr val="FFFFFF">
+                  <a:alpha val="100000"/>
+                </a:srgbClr>
+              </a:solidFill>
+              <a:prstDash val="solid"/>
+              <a:miter/>
+            </a:ln>
+          </p:spPr>
+          <p:txBody>
+            <a:bodyPr/>
+            <a:lstStyle/>
+            <a:p/>
+          </p:txBody>
+        </p:sp>
+        <p:sp>
+          <p:nvSpPr>
+            <p:cNvPr id="14" name="rc14"/>
+            <p:cNvSpPr/>
+            <p:nvPr/>
+          </p:nvSpPr>
+          <p:spPr>
+            <a:xfrm>
+              <a:off x="6944699" y="2939178"/>
+              <a:ext cx="1173348" cy="822185"/>
+            </a:xfrm>
+            <a:prstGeom prst="rect">
+              <a:avLst/>
+            </a:prstGeom>
+            <a:solidFill>
+              <a:srgbClr val="4F86C6">
+                <a:alpha val="100000"/>
+              </a:srgbClr>
+            </a:solidFill>
+            <a:ln w="24391" cap="flat">
+              <a:solidFill>
+                <a:srgbClr val="FFFFFF">
+                  <a:alpha val="100000"/>
+                </a:srgbClr>
+              </a:solidFill>
+              <a:prstDash val="solid"/>
+              <a:miter/>
+            </a:ln>
+          </p:spPr>
+          <p:txBody>
+            <a:bodyPr/>
+            <a:lstStyle/>
+            <a:p/>
+          </p:txBody>
+        </p:sp>
+        <p:sp>
+          <p:nvSpPr>
+            <p:cNvPr id="15" name="rc15"/>
+            <p:cNvSpPr/>
+            <p:nvPr/>
+          </p:nvSpPr>
+          <p:spPr>
+            <a:xfrm>
+              <a:off x="4598003" y="3761364"/>
+              <a:ext cx="1173348" cy="822185"/>
+            </a:xfrm>
+            <a:prstGeom prst="rect">
+              <a:avLst/>
+            </a:prstGeom>
+            <a:solidFill>
+              <a:srgbClr val="4F86C6">
+                <a:alpha val="100000"/>
+              </a:srgbClr>
+            </a:solidFill>
+            <a:ln w="24391" cap="flat">
+              <a:solidFill>
+                <a:srgbClr val="FFFFFF">
+                  <a:alpha val="100000"/>
+                </a:srgbClr>
+              </a:solidFill>
+              <a:prstDash val="solid"/>
+              <a:miter/>
+            </a:ln>
+          </p:spPr>
+          <p:txBody>
+            <a:bodyPr/>
+            <a:lstStyle/>
+            <a:p/>
+          </p:txBody>
+        </p:sp>
+        <p:sp>
+          <p:nvSpPr>
+            <p:cNvPr id="16" name="rc16"/>
+            <p:cNvSpPr/>
+            <p:nvPr/>
+          </p:nvSpPr>
+          <p:spPr>
+            <a:xfrm>
+              <a:off x="5771351" y="3761364"/>
+              <a:ext cx="1173348" cy="822185"/>
+            </a:xfrm>
+            <a:prstGeom prst="rect">
+              <a:avLst/>
+            </a:prstGeom>
+            <a:solidFill>
+              <a:srgbClr val="4F86C6">
+                <a:alpha val="100000"/>
+              </a:srgbClr>
+            </a:solidFill>
+            <a:ln w="24391" cap="flat">
+              <a:solidFill>
+                <a:srgbClr val="FFFFFF">
+                  <a:alpha val="100000"/>
+                </a:srgbClr>
+              </a:solidFill>
+              <a:prstDash val="solid"/>
+              <a:miter/>
+            </a:ln>
+          </p:spPr>
+          <p:txBody>
+            <a:bodyPr/>
+            <a:lstStyle/>
+            <a:p/>
+          </p:txBody>
+        </p:sp>
+        <p:sp>
+          <p:nvSpPr>
+            <p:cNvPr id="17" name="rc17"/>
+            <p:cNvSpPr/>
+            <p:nvPr/>
+          </p:nvSpPr>
+          <p:spPr>
+            <a:xfrm>
+              <a:off x="6944699" y="3761364"/>
+              <a:ext cx="1173348" cy="822185"/>
+            </a:xfrm>
+            <a:prstGeom prst="rect">
+              <a:avLst/>
+            </a:prstGeom>
+            <a:solidFill>
+              <a:srgbClr val="4F86C6">
+                <a:alpha val="100000"/>
+              </a:srgbClr>
+            </a:solidFill>
+            <a:ln w="24391" cap="flat">
+              <a:solidFill>
+                <a:srgbClr val="FFFFFF">
+                  <a:alpha val="100000"/>
+                </a:srgbClr>
+              </a:solidFill>
+              <a:prstDash val="solid"/>
+              <a:miter/>
+            </a:ln>
+          </p:spPr>
+          <p:txBody>
+            <a:bodyPr/>
+            <a:lstStyle/>
+            <a:p/>
+          </p:txBody>
+        </p:sp>
+        <p:sp>
+          <p:nvSpPr>
+            <p:cNvPr id="18" name="rc18"/>
+            <p:cNvSpPr/>
+            <p:nvPr/>
+          </p:nvSpPr>
+          <p:spPr>
+            <a:xfrm>
+              <a:off x="4598003" y="4583550"/>
+              <a:ext cx="1173348" cy="822185"/>
+            </a:xfrm>
+            <a:prstGeom prst="rect">
+              <a:avLst/>
+            </a:prstGeom>
+            <a:solidFill>
+              <a:srgbClr val="4F86C6">
+                <a:alpha val="100000"/>
+              </a:srgbClr>
+            </a:solidFill>
+            <a:ln w="24391" cap="flat">
+              <a:solidFill>
+                <a:srgbClr val="FFFFFF">
+                  <a:alpha val="100000"/>
+                </a:srgbClr>
+              </a:solidFill>
+              <a:prstDash val="solid"/>
+              <a:miter/>
+            </a:ln>
+          </p:spPr>
+          <p:txBody>
+            <a:bodyPr/>
+            <a:lstStyle/>
+            <a:p/>
+          </p:txBody>
+        </p:sp>
+        <p:sp>
+          <p:nvSpPr>
+            <p:cNvPr id="19" name="rc19"/>
+            <p:cNvSpPr/>
+            <p:nvPr/>
+          </p:nvSpPr>
+          <p:spPr>
+            <a:xfrm>
+              <a:off x="5771351" y="4583550"/>
+              <a:ext cx="1173348" cy="822185"/>
+            </a:xfrm>
+            <a:prstGeom prst="rect">
+              <a:avLst/>
+            </a:prstGeom>
+            <a:solidFill>
+              <a:srgbClr val="4F86C6">
+                <a:alpha val="100000"/>
+              </a:srgbClr>
+            </a:solidFill>
+            <a:ln w="24391" cap="flat">
+              <a:solidFill>
+                <a:srgbClr val="FFFFFF">
+                  <a:alpha val="100000"/>
+                </a:srgbClr>
+              </a:solidFill>
+              <a:prstDash val="solid"/>
+              <a:miter/>
+            </a:ln>
+          </p:spPr>
+          <p:txBody>
+            <a:bodyPr/>
+            <a:lstStyle/>
+            <a:p/>
+          </p:txBody>
+        </p:sp>
+        <p:sp>
+          <p:nvSpPr>
+            <p:cNvPr id="20" name="rc20"/>
+            <p:cNvSpPr/>
+            <p:nvPr/>
+          </p:nvSpPr>
+          <p:spPr>
+            <a:xfrm>
+              <a:off x="6944699" y="4583550"/>
+              <a:ext cx="1173348" cy="822185"/>
+            </a:xfrm>
+            <a:prstGeom prst="rect">
+              <a:avLst/>
+            </a:prstGeom>
+            <a:solidFill>
+              <a:srgbClr val="4F86C6">
+                <a:alpha val="100000"/>
+              </a:srgbClr>
+            </a:solidFill>
+            <a:ln w="24391" cap="flat">
+              <a:solidFill>
+                <a:srgbClr val="FFFFFF">
+                  <a:alpha val="100000"/>
+                </a:srgbClr>
+              </a:solidFill>
+              <a:prstDash val="solid"/>
+              <a:miter/>
+            </a:ln>
+          </p:spPr>
+          <p:txBody>
+            <a:bodyPr/>
+            <a:lstStyle/>
+            <a:p/>
+          </p:txBody>
+        </p:sp>
+        <p:sp>
+          <p:nvSpPr>
+            <p:cNvPr id="21" name="tx21"/>
+            <p:cNvSpPr/>
+            <p:nvPr/>
+          </p:nvSpPr>
+          <p:spPr>
+            <a:xfrm>
+              <a:off x="5054069" y="1660777"/>
+              <a:ext cx="261216" cy="90245"/>
+            </a:xfrm>
+            <a:prstGeom prst="rect">
+              <a:avLst/>
+            </a:prstGeom>
+            <a:noFill/>
+          </p:spPr>
+          <p:txBody>
+            <a:bodyPr lIns="0" rIns="0" tIns="0" bIns="0" anchorCtr="1" anchor="ctr" wrap="none"/>
+            <a:lstStyle/>
+            <a:p>
+              <a:pPr algn="l" marL="0" marR="0" indent="0">
+                <a:lnSpc>
+                  <a:spcPts val="1081"/>
+                </a:lnSpc>
+                <a:spcBef>
+                  <a:spcPts val="0"/>
+                </a:spcBef>
+                <a:spcAft>
+                  <a:spcPts val="0"/>
+                </a:spcAft>
+              </a:pPr>
+              <a:r>
+                <a:rPr sz="1081" b="1">
+                  <a:solidFill>
+                    <a:srgbClr val="1A1A1A">
+                      <a:alpha val="100000"/>
+                    </a:srgbClr>
+                  </a:solidFill>
+                  <a:latin typeface="Aptos"/>
+                  <a:cs typeface="Aptos"/>
+                </a:rPr>
+                <a:t>2.89</a:t>
+              </a:r>
+            </a:p>
+          </p:txBody>
+        </p:sp>
+        <p:sp>
+          <p:nvSpPr>
+            <p:cNvPr id="22" name="tx22"/>
+            <p:cNvSpPr/>
+            <p:nvPr/>
+          </p:nvSpPr>
+          <p:spPr>
+            <a:xfrm>
+              <a:off x="6227417" y="1660777"/>
+              <a:ext cx="261216" cy="90245"/>
+            </a:xfrm>
+            <a:prstGeom prst="rect">
+              <a:avLst/>
+            </a:prstGeom>
+            <a:noFill/>
+          </p:spPr>
+          <p:txBody>
+            <a:bodyPr lIns="0" rIns="0" tIns="0" bIns="0" anchorCtr="1" anchor="ctr" wrap="none"/>
+            <a:lstStyle/>
+            <a:p>
+              <a:pPr algn="l" marL="0" marR="0" indent="0">
+                <a:lnSpc>
+                  <a:spcPts val="1081"/>
+                </a:lnSpc>
+                <a:spcBef>
+                  <a:spcPts val="0"/>
+                </a:spcBef>
+                <a:spcAft>
+                  <a:spcPts val="0"/>
+                </a:spcAft>
+              </a:pPr>
+              <a:r>
+                <a:rPr sz="1081" b="1">
+                  <a:solidFill>
+                    <a:srgbClr val="1A1A1A">
+                      <a:alpha val="100000"/>
+                    </a:srgbClr>
+                  </a:solidFill>
+                  <a:latin typeface="Aptos"/>
+                  <a:cs typeface="Aptos"/>
+                </a:rPr>
+                <a:t>2.86</a:t>
+              </a:r>
+            </a:p>
+          </p:txBody>
+        </p:sp>
+        <p:sp>
+          <p:nvSpPr>
+            <p:cNvPr id="23" name="tx23"/>
+            <p:cNvSpPr/>
+            <p:nvPr/>
+          </p:nvSpPr>
+          <p:spPr>
+            <a:xfrm>
+              <a:off x="7400765" y="1660777"/>
+              <a:ext cx="261216" cy="90245"/>
+            </a:xfrm>
+            <a:prstGeom prst="rect">
+              <a:avLst/>
+            </a:prstGeom>
+            <a:noFill/>
+          </p:spPr>
+          <p:txBody>
+            <a:bodyPr lIns="0" rIns="0" tIns="0" bIns="0" anchorCtr="1" anchor="ctr" wrap="none"/>
+            <a:lstStyle/>
+            <a:p>
+              <a:pPr algn="l" marL="0" marR="0" indent="0">
+                <a:lnSpc>
+                  <a:spcPts val="1081"/>
+                </a:lnSpc>
+                <a:spcBef>
+                  <a:spcPts val="0"/>
+                </a:spcBef>
+                <a:spcAft>
+                  <a:spcPts val="0"/>
+                </a:spcAft>
+              </a:pPr>
+              <a:r>
+                <a:rPr sz="1081" b="1">
+                  <a:solidFill>
+                    <a:srgbClr val="1A1A1A">
+                      <a:alpha val="100000"/>
+                    </a:srgbClr>
+                  </a:solidFill>
+                  <a:latin typeface="Aptos"/>
+                  <a:cs typeface="Aptos"/>
+                </a:rPr>
+                <a:t>0.88</a:t>
+              </a:r>
+            </a:p>
+          </p:txBody>
+        </p:sp>
+        <p:sp>
+          <p:nvSpPr>
+            <p:cNvPr id="24" name="tx24"/>
+            <p:cNvSpPr/>
+            <p:nvPr/>
+          </p:nvSpPr>
+          <p:spPr>
+            <a:xfrm>
+              <a:off x="5054069" y="2482963"/>
+              <a:ext cx="261216" cy="90245"/>
+            </a:xfrm>
+            <a:prstGeom prst="rect">
+              <a:avLst/>
+            </a:prstGeom>
+            <a:noFill/>
+          </p:spPr>
+          <p:txBody>
+            <a:bodyPr lIns="0" rIns="0" tIns="0" bIns="0" anchorCtr="1" anchor="ctr" wrap="none"/>
+            <a:lstStyle/>
+            <a:p>
+              <a:pPr algn="l" marL="0" marR="0" indent="0">
+                <a:lnSpc>
+                  <a:spcPts val="1081"/>
+                </a:lnSpc>
+                <a:spcBef>
+                  <a:spcPts val="0"/>
+                </a:spcBef>
+                <a:spcAft>
+                  <a:spcPts val="0"/>
+                </a:spcAft>
+              </a:pPr>
+              <a:r>
+                <a:rPr sz="1081" b="1">
+                  <a:solidFill>
+                    <a:srgbClr val="1A1A1A">
+                      <a:alpha val="100000"/>
+                    </a:srgbClr>
+                  </a:solidFill>
+                  <a:latin typeface="Aptos"/>
+                  <a:cs typeface="Aptos"/>
+                </a:rPr>
+                <a:t>2.89</a:t>
+              </a:r>
+            </a:p>
+          </p:txBody>
+        </p:sp>
+        <p:sp>
+          <p:nvSpPr>
+            <p:cNvPr id="25" name="tx25"/>
+            <p:cNvSpPr/>
+            <p:nvPr/>
+          </p:nvSpPr>
+          <p:spPr>
+            <a:xfrm>
+              <a:off x="6227417" y="2482963"/>
+              <a:ext cx="261216" cy="90245"/>
+            </a:xfrm>
+            <a:prstGeom prst="rect">
+              <a:avLst/>
+            </a:prstGeom>
+            <a:noFill/>
+          </p:spPr>
+          <p:txBody>
+            <a:bodyPr lIns="0" rIns="0" tIns="0" bIns="0" anchorCtr="1" anchor="ctr" wrap="none"/>
+            <a:lstStyle/>
+            <a:p>
+              <a:pPr algn="l" marL="0" marR="0" indent="0">
+                <a:lnSpc>
+                  <a:spcPts val="1081"/>
+                </a:lnSpc>
+                <a:spcBef>
+                  <a:spcPts val="0"/>
+                </a:spcBef>
+                <a:spcAft>
+                  <a:spcPts val="0"/>
+                </a:spcAft>
+              </a:pPr>
+              <a:r>
+                <a:rPr sz="1081" b="1">
+                  <a:solidFill>
+                    <a:srgbClr val="1A1A1A">
+                      <a:alpha val="100000"/>
+                    </a:srgbClr>
+                  </a:solidFill>
+                  <a:latin typeface="Aptos"/>
+                  <a:cs typeface="Aptos"/>
+                </a:rPr>
+                <a:t>2.91</a:t>
+              </a:r>
+            </a:p>
+          </p:txBody>
+        </p:sp>
+        <p:sp>
+          <p:nvSpPr>
+            <p:cNvPr id="26" name="tx26"/>
+            <p:cNvSpPr/>
+            <p:nvPr/>
+          </p:nvSpPr>
+          <p:spPr>
+            <a:xfrm>
+              <a:off x="7400765" y="2482963"/>
+              <a:ext cx="261216" cy="90245"/>
+            </a:xfrm>
+            <a:prstGeom prst="rect">
+              <a:avLst/>
+            </a:prstGeom>
+            <a:noFill/>
+          </p:spPr>
+          <p:txBody>
+            <a:bodyPr lIns="0" rIns="0" tIns="0" bIns="0" anchorCtr="1" anchor="ctr" wrap="none"/>
+            <a:lstStyle/>
+            <a:p>
+              <a:pPr algn="l" marL="0" marR="0" indent="0">
+                <a:lnSpc>
+                  <a:spcPts val="1081"/>
+                </a:lnSpc>
+                <a:spcBef>
+                  <a:spcPts val="0"/>
+                </a:spcBef>
+                <a:spcAft>
+                  <a:spcPts val="0"/>
+                </a:spcAft>
+              </a:pPr>
+              <a:r>
+                <a:rPr sz="1081" b="1">
+                  <a:solidFill>
+                    <a:srgbClr val="1A1A1A">
+                      <a:alpha val="100000"/>
+                    </a:srgbClr>
+                  </a:solidFill>
+                  <a:latin typeface="Aptos"/>
+                  <a:cs typeface="Aptos"/>
+                </a:rPr>
+                <a:t>0.82</a:t>
+              </a:r>
+            </a:p>
+          </p:txBody>
+        </p:sp>
+        <p:sp>
+          <p:nvSpPr>
+            <p:cNvPr id="27" name="tx27"/>
+            <p:cNvSpPr/>
+            <p:nvPr/>
+          </p:nvSpPr>
+          <p:spPr>
+            <a:xfrm>
+              <a:off x="5054069" y="3305148"/>
+              <a:ext cx="261216" cy="90245"/>
+            </a:xfrm>
+            <a:prstGeom prst="rect">
+              <a:avLst/>
+            </a:prstGeom>
+            <a:noFill/>
+          </p:spPr>
+          <p:txBody>
+            <a:bodyPr lIns="0" rIns="0" tIns="0" bIns="0" anchorCtr="1" anchor="ctr" wrap="none"/>
+            <a:lstStyle/>
+            <a:p>
+              <a:pPr algn="l" marL="0" marR="0" indent="0">
+                <a:lnSpc>
+                  <a:spcPts val="1081"/>
+                </a:lnSpc>
+                <a:spcBef>
+                  <a:spcPts val="0"/>
+                </a:spcBef>
+                <a:spcAft>
+                  <a:spcPts val="0"/>
+                </a:spcAft>
+              </a:pPr>
+              <a:r>
+                <a:rPr sz="1081" b="1">
+                  <a:solidFill>
+                    <a:srgbClr val="1A1A1A">
+                      <a:alpha val="100000"/>
+                    </a:srgbClr>
+                  </a:solidFill>
+                  <a:latin typeface="Aptos"/>
+                  <a:cs typeface="Aptos"/>
+                </a:rPr>
+                <a:t>2.93</a:t>
+              </a:r>
+            </a:p>
+          </p:txBody>
+        </p:sp>
+        <p:sp>
+          <p:nvSpPr>
+            <p:cNvPr id="28" name="tx28"/>
+            <p:cNvSpPr/>
+            <p:nvPr/>
+          </p:nvSpPr>
+          <p:spPr>
+            <a:xfrm>
+              <a:off x="6227417" y="3305148"/>
+              <a:ext cx="261216" cy="90245"/>
+            </a:xfrm>
+            <a:prstGeom prst="rect">
+              <a:avLst/>
+            </a:prstGeom>
+            <a:noFill/>
+          </p:spPr>
+          <p:txBody>
+            <a:bodyPr lIns="0" rIns="0" tIns="0" bIns="0" anchorCtr="1" anchor="ctr" wrap="none"/>
+            <a:lstStyle/>
+            <a:p>
+              <a:pPr algn="l" marL="0" marR="0" indent="0">
+                <a:lnSpc>
+                  <a:spcPts val="1081"/>
+                </a:lnSpc>
+                <a:spcBef>
+                  <a:spcPts val="0"/>
+                </a:spcBef>
+                <a:spcAft>
+                  <a:spcPts val="0"/>
+                </a:spcAft>
+              </a:pPr>
+              <a:r>
+                <a:rPr sz="1081" b="1">
+                  <a:solidFill>
+                    <a:srgbClr val="1A1A1A">
+                      <a:alpha val="100000"/>
+                    </a:srgbClr>
+                  </a:solidFill>
+                  <a:latin typeface="Aptos"/>
+                  <a:cs typeface="Aptos"/>
+                </a:rPr>
+                <a:t>3.00</a:t>
+              </a:r>
+            </a:p>
+          </p:txBody>
+        </p:sp>
+        <p:sp>
+          <p:nvSpPr>
+            <p:cNvPr id="29" name="tx29"/>
+            <p:cNvSpPr/>
+            <p:nvPr/>
+          </p:nvSpPr>
+          <p:spPr>
+            <a:xfrm>
+              <a:off x="7400765" y="3305148"/>
+              <a:ext cx="261216" cy="90245"/>
+            </a:xfrm>
+            <a:prstGeom prst="rect">
+              <a:avLst/>
+            </a:prstGeom>
+            <a:noFill/>
+          </p:spPr>
+          <p:txBody>
+            <a:bodyPr lIns="0" rIns="0" tIns="0" bIns="0" anchorCtr="1" anchor="ctr" wrap="none"/>
+            <a:lstStyle/>
+            <a:p>
+              <a:pPr algn="l" marL="0" marR="0" indent="0">
+                <a:lnSpc>
+                  <a:spcPts val="1081"/>
+                </a:lnSpc>
+                <a:spcBef>
+                  <a:spcPts val="0"/>
+                </a:spcBef>
+                <a:spcAft>
+                  <a:spcPts val="0"/>
+                </a:spcAft>
+              </a:pPr>
+              <a:r>
+                <a:rPr sz="1081" b="1">
+                  <a:solidFill>
+                    <a:srgbClr val="1A1A1A">
+                      <a:alpha val="100000"/>
+                    </a:srgbClr>
+                  </a:solidFill>
+                  <a:latin typeface="Aptos"/>
+                  <a:cs typeface="Aptos"/>
+                </a:rPr>
+                <a:t>0.90</a:t>
+              </a:r>
+            </a:p>
+          </p:txBody>
+        </p:sp>
+        <p:sp>
+          <p:nvSpPr>
+            <p:cNvPr id="30" name="tx30"/>
+            <p:cNvSpPr/>
+            <p:nvPr/>
+          </p:nvSpPr>
+          <p:spPr>
+            <a:xfrm>
+              <a:off x="5054069" y="4127334"/>
+              <a:ext cx="261216" cy="90245"/>
+            </a:xfrm>
+            <a:prstGeom prst="rect">
+              <a:avLst/>
+            </a:prstGeom>
+            <a:noFill/>
+          </p:spPr>
+          <p:txBody>
+            <a:bodyPr lIns="0" rIns="0" tIns="0" bIns="0" anchorCtr="1" anchor="ctr" wrap="none"/>
+            <a:lstStyle/>
+            <a:p>
+              <a:pPr algn="l" marL="0" marR="0" indent="0">
+                <a:lnSpc>
+                  <a:spcPts val="1081"/>
+                </a:lnSpc>
+                <a:spcBef>
+                  <a:spcPts val="0"/>
+                </a:spcBef>
+                <a:spcAft>
+                  <a:spcPts val="0"/>
+                </a:spcAft>
+              </a:pPr>
+              <a:r>
+                <a:rPr sz="1081" b="1">
+                  <a:solidFill>
+                    <a:srgbClr val="1A1A1A">
+                      <a:alpha val="100000"/>
+                    </a:srgbClr>
+                  </a:solidFill>
+                  <a:latin typeface="Aptos"/>
+                  <a:cs typeface="Aptos"/>
+                </a:rPr>
+                <a:t>2.88</a:t>
+              </a:r>
+            </a:p>
+          </p:txBody>
+        </p:sp>
+        <p:sp>
+          <p:nvSpPr>
+            <p:cNvPr id="31" name="tx31"/>
+            <p:cNvSpPr/>
+            <p:nvPr/>
+          </p:nvSpPr>
+          <p:spPr>
+            <a:xfrm>
+              <a:off x="6227417" y="4127334"/>
+              <a:ext cx="261216" cy="90245"/>
+            </a:xfrm>
+            <a:prstGeom prst="rect">
+              <a:avLst/>
+            </a:prstGeom>
+            <a:noFill/>
+          </p:spPr>
+          <p:txBody>
+            <a:bodyPr lIns="0" rIns="0" tIns="0" bIns="0" anchorCtr="1" anchor="ctr" wrap="none"/>
+            <a:lstStyle/>
+            <a:p>
+              <a:pPr algn="l" marL="0" marR="0" indent="0">
+                <a:lnSpc>
+                  <a:spcPts val="1081"/>
+                </a:lnSpc>
+                <a:spcBef>
+                  <a:spcPts val="0"/>
+                </a:spcBef>
+                <a:spcAft>
+                  <a:spcPts val="0"/>
+                </a:spcAft>
+              </a:pPr>
+              <a:r>
+                <a:rPr sz="1081" b="1">
+                  <a:solidFill>
+                    <a:srgbClr val="1A1A1A">
+                      <a:alpha val="100000"/>
+                    </a:srgbClr>
+                  </a:solidFill>
+                  <a:latin typeface="Aptos"/>
+                  <a:cs typeface="Aptos"/>
+                </a:rPr>
+                <a:t>2.81</a:t>
+              </a:r>
+            </a:p>
+          </p:txBody>
+        </p:sp>
+        <p:sp>
+          <p:nvSpPr>
+            <p:cNvPr id="32" name="tx32"/>
+            <p:cNvSpPr/>
+            <p:nvPr/>
+          </p:nvSpPr>
+          <p:spPr>
+            <a:xfrm>
+              <a:off x="7400765" y="4127334"/>
+              <a:ext cx="261216" cy="90245"/>
+            </a:xfrm>
+            <a:prstGeom prst="rect">
+              <a:avLst/>
+            </a:prstGeom>
+            <a:noFill/>
+          </p:spPr>
+          <p:txBody>
+            <a:bodyPr lIns="0" rIns="0" tIns="0" bIns="0" anchorCtr="1" anchor="ctr" wrap="none"/>
+            <a:lstStyle/>
+            <a:p>
+              <a:pPr algn="l" marL="0" marR="0" indent="0">
+                <a:lnSpc>
+                  <a:spcPts val="1081"/>
+                </a:lnSpc>
+                <a:spcBef>
+                  <a:spcPts val="0"/>
+                </a:spcBef>
+                <a:spcAft>
+                  <a:spcPts val="0"/>
+                </a:spcAft>
+              </a:pPr>
+              <a:r>
+                <a:rPr sz="1081" b="1">
+                  <a:solidFill>
+                    <a:srgbClr val="1A1A1A">
+                      <a:alpha val="100000"/>
+                    </a:srgbClr>
+                  </a:solidFill>
+                  <a:latin typeface="Aptos"/>
+                  <a:cs typeface="Aptos"/>
+                </a:rPr>
+                <a:t>0.75</a:t>
+              </a:r>
+            </a:p>
+          </p:txBody>
+        </p:sp>
+        <p:sp>
+          <p:nvSpPr>
+            <p:cNvPr id="33" name="tx33"/>
+            <p:cNvSpPr/>
+            <p:nvPr/>
+          </p:nvSpPr>
+          <p:spPr>
+            <a:xfrm>
+              <a:off x="5054069" y="4949520"/>
+              <a:ext cx="261216" cy="90245"/>
+            </a:xfrm>
+            <a:prstGeom prst="rect">
+              <a:avLst/>
+            </a:prstGeom>
+            <a:noFill/>
+          </p:spPr>
+          <p:txBody>
+            <a:bodyPr lIns="0" rIns="0" tIns="0" bIns="0" anchorCtr="1" anchor="ctr" wrap="none"/>
+            <a:lstStyle/>
+            <a:p>
+              <a:pPr algn="l" marL="0" marR="0" indent="0">
+                <a:lnSpc>
+                  <a:spcPts val="1081"/>
+                </a:lnSpc>
+                <a:spcBef>
+                  <a:spcPts val="0"/>
+                </a:spcBef>
+                <a:spcAft>
+                  <a:spcPts val="0"/>
+                </a:spcAft>
+              </a:pPr>
+              <a:r>
+                <a:rPr sz="1081" b="1">
+                  <a:solidFill>
+                    <a:srgbClr val="1A1A1A">
+                      <a:alpha val="100000"/>
+                    </a:srgbClr>
+                  </a:solidFill>
+                  <a:latin typeface="Aptos"/>
+                  <a:cs typeface="Aptos"/>
+                </a:rPr>
+                <a:t>2.89</a:t>
+              </a:r>
+            </a:p>
+          </p:txBody>
+        </p:sp>
+        <p:sp>
+          <p:nvSpPr>
+            <p:cNvPr id="34" name="tx34"/>
+            <p:cNvSpPr/>
+            <p:nvPr/>
+          </p:nvSpPr>
+          <p:spPr>
+            <a:xfrm>
+              <a:off x="6227417" y="4949520"/>
+              <a:ext cx="261216" cy="90245"/>
+            </a:xfrm>
+            <a:prstGeom prst="rect">
+              <a:avLst/>
+            </a:prstGeom>
+            <a:noFill/>
+          </p:spPr>
+          <p:txBody>
+            <a:bodyPr lIns="0" rIns="0" tIns="0" bIns="0" anchorCtr="1" anchor="ctr" wrap="none"/>
+            <a:lstStyle/>
+            <a:p>
+              <a:pPr algn="l" marL="0" marR="0" indent="0">
+                <a:lnSpc>
+                  <a:spcPts val="1081"/>
+                </a:lnSpc>
+                <a:spcBef>
+                  <a:spcPts val="0"/>
+                </a:spcBef>
+                <a:spcAft>
+                  <a:spcPts val="0"/>
+                </a:spcAft>
+              </a:pPr>
+              <a:r>
+                <a:rPr sz="1081" b="1">
+                  <a:solidFill>
+                    <a:srgbClr val="1A1A1A">
+                      <a:alpha val="100000"/>
+                    </a:srgbClr>
+                  </a:solidFill>
+                  <a:latin typeface="Aptos"/>
+                  <a:cs typeface="Aptos"/>
+                </a:rPr>
+                <a:t>2.86</a:t>
+              </a:r>
+            </a:p>
+          </p:txBody>
+        </p:sp>
+        <p:sp>
+          <p:nvSpPr>
+            <p:cNvPr id="35" name="tx35"/>
+            <p:cNvSpPr/>
+            <p:nvPr/>
+          </p:nvSpPr>
+          <p:spPr>
+            <a:xfrm>
+              <a:off x="7400765" y="4949520"/>
+              <a:ext cx="261216" cy="90245"/>
+            </a:xfrm>
+            <a:prstGeom prst="rect">
+              <a:avLst/>
+            </a:prstGeom>
+            <a:noFill/>
+          </p:spPr>
+          <p:txBody>
+            <a:bodyPr lIns="0" rIns="0" tIns="0" bIns="0" anchorCtr="1" anchor="ctr" wrap="none"/>
+            <a:lstStyle/>
+            <a:p>
+              <a:pPr algn="l" marL="0" marR="0" indent="0">
+                <a:lnSpc>
+                  <a:spcPts val="1081"/>
+                </a:lnSpc>
+                <a:spcBef>
+                  <a:spcPts val="0"/>
+                </a:spcBef>
+                <a:spcAft>
+                  <a:spcPts val="0"/>
+                </a:spcAft>
+              </a:pPr>
+              <a:r>
+                <a:rPr sz="1081" b="1">
+                  <a:solidFill>
+                    <a:srgbClr val="1A1A1A">
+                      <a:alpha val="100000"/>
+                    </a:srgbClr>
+                  </a:solidFill>
+                  <a:latin typeface="Aptos"/>
+                  <a:cs typeface="Aptos"/>
+                </a:rPr>
+                <a:t>0.82</a:t>
+              </a:r>
+            </a:p>
+          </p:txBody>
+        </p:sp>
+        <p:sp>
+          <p:nvSpPr>
+            <p:cNvPr id="36" name="tx36"/>
+            <p:cNvSpPr/>
+            <p:nvPr/>
+          </p:nvSpPr>
+          <p:spPr>
+            <a:xfrm>
+              <a:off x="3114229" y="4930274"/>
+              <a:ext cx="1303176" cy="106102"/>
+            </a:xfrm>
+            <a:prstGeom prst="rect">
+              <a:avLst/>
+            </a:prstGeom>
+            <a:noFill/>
+          </p:spPr>
+          <p:txBody>
+            <a:bodyPr lIns="0" rIns="0" tIns="0" bIns="0" anchorCtr="1" anchor="ctr" wrap="none"/>
+            <a:lstStyle/>
+            <a:p>
+              <a:pPr algn="l" marL="0" marR="0" indent="0">
+                <a:lnSpc>
+                  <a:spcPts val="1000"/>
+                </a:lnSpc>
+                <a:spcBef>
+                  <a:spcPts val="0"/>
+                </a:spcBef>
+                <a:spcAft>
+                  <a:spcPts val="0"/>
+                </a:spcAft>
+              </a:pPr>
+              <a:r>
+                <a:rPr sz="1000">
+                  <a:solidFill>
+                    <a:srgbClr val="000000">
+                      <a:alpha val="100000"/>
+                    </a:srgbClr>
+                  </a:solidFill>
+                  <a:latin typeface="Aptos"/>
+                  <a:cs typeface="Aptos"/>
+                </a:rPr>
+                <a:t>Main Model (+ All Three)</a:t>
+              </a:r>
+            </a:p>
+          </p:txBody>
+        </p:sp>
+        <p:sp>
+          <p:nvSpPr>
+            <p:cNvPr id="37" name="tx37"/>
+            <p:cNvSpPr/>
+            <p:nvPr/>
+          </p:nvSpPr>
+          <p:spPr>
+            <a:xfrm>
+              <a:off x="2837657" y="4107407"/>
+              <a:ext cx="1579748" cy="106784"/>
+            </a:xfrm>
+            <a:prstGeom prst="rect">
+              <a:avLst/>
+            </a:prstGeom>
+            <a:noFill/>
+          </p:spPr>
+          <p:txBody>
+            <a:bodyPr lIns="0" rIns="0" tIns="0" bIns="0" anchorCtr="1" anchor="ctr" wrap="none"/>
+            <a:lstStyle/>
+            <a:p>
+              <a:pPr algn="l" marL="0" marR="0" indent="0">
+                <a:lnSpc>
+                  <a:spcPts val="1000"/>
+                </a:lnSpc>
+                <a:spcBef>
+                  <a:spcPts val="0"/>
+                </a:spcBef>
+                <a:spcAft>
+                  <a:spcPts val="0"/>
+                </a:spcAft>
+              </a:pPr>
+              <a:r>
+                <a:rPr sz="1000">
+                  <a:solidFill>
+                    <a:srgbClr val="000000">
+                      <a:alpha val="100000"/>
+                    </a:srgbClr>
+                  </a:solidFill>
+                  <a:latin typeface="Aptos"/>
+                  <a:cs typeface="Aptos"/>
+                </a:rPr>
+                <a:t>+ Mean Airway Pressure Only</a:t>
+              </a:r>
+            </a:p>
+          </p:txBody>
+        </p:sp>
+        <p:sp>
+          <p:nvSpPr>
+            <p:cNvPr id="38" name="tx38"/>
+            <p:cNvSpPr/>
+            <p:nvPr/>
+          </p:nvSpPr>
+          <p:spPr>
+            <a:xfrm>
+              <a:off x="3332200" y="3285221"/>
+              <a:ext cx="1085205" cy="106784"/>
+            </a:xfrm>
+            <a:prstGeom prst="rect">
+              <a:avLst/>
+            </a:prstGeom>
+            <a:noFill/>
+          </p:spPr>
+          <p:txBody>
+            <a:bodyPr lIns="0" rIns="0" tIns="0" bIns="0" anchorCtr="1" anchor="ctr" wrap="none"/>
+            <a:lstStyle/>
+            <a:p>
+              <a:pPr algn="l" marL="0" marR="0" indent="0">
+                <a:lnSpc>
+                  <a:spcPts val="1000"/>
+                </a:lnSpc>
+                <a:spcBef>
+                  <a:spcPts val="0"/>
+                </a:spcBef>
+                <a:spcAft>
+                  <a:spcPts val="0"/>
+                </a:spcAft>
+              </a:pPr>
+              <a:r>
+                <a:rPr sz="1000">
+                  <a:solidFill>
+                    <a:srgbClr val="000000">
+                      <a:alpha val="100000"/>
+                    </a:srgbClr>
+                  </a:solidFill>
+                  <a:latin typeface="Aptos"/>
+                  <a:cs typeface="Aptos"/>
+                </a:rPr>
+                <a:t>+ Tidal Volume Only</a:t>
+              </a:r>
+            </a:p>
+          </p:txBody>
+        </p:sp>
+        <p:sp>
+          <p:nvSpPr>
+            <p:cNvPr id="39" name="tx39"/>
+            <p:cNvSpPr/>
+            <p:nvPr/>
+          </p:nvSpPr>
+          <p:spPr>
+            <a:xfrm>
+              <a:off x="3138165" y="2463035"/>
+              <a:ext cx="1279239" cy="106784"/>
+            </a:xfrm>
+            <a:prstGeom prst="rect">
+              <a:avLst/>
+            </a:prstGeom>
+            <a:noFill/>
+          </p:spPr>
+          <p:txBody>
+            <a:bodyPr lIns="0" rIns="0" tIns="0" bIns="0" anchorCtr="1" anchor="ctr" wrap="none"/>
+            <a:lstStyle/>
+            <a:p>
+              <a:pPr algn="l" marL="0" marR="0" indent="0">
+                <a:lnSpc>
+                  <a:spcPts val="1000"/>
+                </a:lnSpc>
+                <a:spcBef>
+                  <a:spcPts val="0"/>
+                </a:spcBef>
+                <a:spcAft>
+                  <a:spcPts val="0"/>
+                </a:spcAft>
+              </a:pPr>
+              <a:r>
+                <a:rPr sz="1000">
+                  <a:solidFill>
+                    <a:srgbClr val="000000">
+                      <a:alpha val="100000"/>
+                    </a:srgbClr>
+                  </a:solidFill>
+                  <a:latin typeface="Aptos"/>
+                  <a:cs typeface="Aptos"/>
+                </a:rPr>
+                <a:t>+ Respiratory Rate Only</a:t>
+              </a:r>
+            </a:p>
+          </p:txBody>
+        </p:sp>
+        <p:sp>
+          <p:nvSpPr>
+            <p:cNvPr id="40" name="tx40"/>
+            <p:cNvSpPr/>
+            <p:nvPr/>
+          </p:nvSpPr>
+          <p:spPr>
+            <a:xfrm>
+              <a:off x="3232981" y="1641532"/>
+              <a:ext cx="1184423" cy="106102"/>
+            </a:xfrm>
+            <a:prstGeom prst="rect">
+              <a:avLst/>
+            </a:prstGeom>
+            <a:noFill/>
+          </p:spPr>
+          <p:txBody>
+            <a:bodyPr lIns="0" rIns="0" tIns="0" bIns="0" anchorCtr="1" anchor="ctr" wrap="none"/>
+            <a:lstStyle/>
+            <a:p>
+              <a:pPr algn="l" marL="0" marR="0" indent="0">
+                <a:lnSpc>
+                  <a:spcPts val="1000"/>
+                </a:lnSpc>
+                <a:spcBef>
+                  <a:spcPts val="0"/>
+                </a:spcBef>
+                <a:spcAft>
+                  <a:spcPts val="0"/>
+                </a:spcAft>
+              </a:pPr>
+              <a:r>
+                <a:rPr sz="1000">
+                  <a:solidFill>
+                    <a:srgbClr val="000000">
+                      <a:alpha val="100000"/>
+                    </a:srgbClr>
+                  </a:solidFill>
+                  <a:latin typeface="Aptos"/>
+                  <a:cs typeface="Aptos"/>
+                </a:rPr>
+                <a:t>Model B (Base Model)</a:t>
+              </a:r>
+            </a:p>
+          </p:txBody>
+        </p:sp>
+        <p:sp>
+          <p:nvSpPr>
+            <p:cNvPr id="41" name="tx41"/>
+            <p:cNvSpPr/>
+            <p:nvPr/>
+          </p:nvSpPr>
+          <p:spPr>
+            <a:xfrm>
+              <a:off x="4909066" y="5509791"/>
+              <a:ext cx="551222" cy="112241"/>
+            </a:xfrm>
+            <a:prstGeom prst="rect">
+              <a:avLst/>
+            </a:prstGeom>
+            <a:noFill/>
+          </p:spPr>
+          <p:txBody>
+            <a:bodyPr lIns="0" rIns="0" tIns="0" bIns="0" anchorCtr="1" anchor="ctr" wrap="none"/>
+            <a:lstStyle/>
+            <a:p>
+              <a:pPr algn="l" marL="0" marR="0" indent="0">
+                <a:lnSpc>
+                  <a:spcPts val="1000"/>
+                </a:lnSpc>
+                <a:spcBef>
+                  <a:spcPts val="0"/>
+                </a:spcBef>
+                <a:spcAft>
+                  <a:spcPts val="0"/>
+                </a:spcAft>
+              </a:pPr>
+              <a:r>
+                <a:rPr sz="1000">
+                  <a:solidFill>
+                    <a:srgbClr val="000000">
+                      <a:alpha val="100000"/>
+                    </a:srgbClr>
+                  </a:solidFill>
+                  <a:latin typeface="Aptos"/>
+                  <a:cs typeface="Aptos"/>
+                </a:rPr>
+                <a:t>Left SctO₂</a:t>
+              </a:r>
+            </a:p>
+          </p:txBody>
+        </p:sp>
+        <p:sp>
+          <p:nvSpPr>
+            <p:cNvPr id="42" name="tx42"/>
+            <p:cNvSpPr/>
+            <p:nvPr/>
+          </p:nvSpPr>
+          <p:spPr>
+            <a:xfrm>
+              <a:off x="6047315" y="5509791"/>
+              <a:ext cx="621419" cy="112241"/>
+            </a:xfrm>
+            <a:prstGeom prst="rect">
+              <a:avLst/>
+            </a:prstGeom>
+            <a:noFill/>
+          </p:spPr>
+          <p:txBody>
+            <a:bodyPr lIns="0" rIns="0" tIns="0" bIns="0" anchorCtr="1" anchor="ctr" wrap="none"/>
+            <a:lstStyle/>
+            <a:p>
+              <a:pPr algn="l" marL="0" marR="0" indent="0">
+                <a:lnSpc>
+                  <a:spcPts val="1000"/>
+                </a:lnSpc>
+                <a:spcBef>
+                  <a:spcPts val="0"/>
+                </a:spcBef>
+                <a:spcAft>
+                  <a:spcPts val="0"/>
+                </a:spcAft>
+              </a:pPr>
+              <a:r>
+                <a:rPr sz="1000">
+                  <a:solidFill>
+                    <a:srgbClr val="000000">
+                      <a:alpha val="100000"/>
+                    </a:srgbClr>
+                  </a:solidFill>
+                  <a:latin typeface="Aptos"/>
+                  <a:cs typeface="Aptos"/>
+                </a:rPr>
+                <a:t>Right SctO₂</a:t>
+              </a:r>
+            </a:p>
+          </p:txBody>
+        </p:sp>
+        <p:sp>
+          <p:nvSpPr>
+            <p:cNvPr id="43" name="tx43"/>
+            <p:cNvSpPr/>
+            <p:nvPr/>
+          </p:nvSpPr>
+          <p:spPr>
+            <a:xfrm>
+              <a:off x="7387692" y="5509791"/>
+              <a:ext cx="287362" cy="112241"/>
+            </a:xfrm>
+            <a:prstGeom prst="rect">
+              <a:avLst/>
+            </a:prstGeom>
+            <a:noFill/>
+          </p:spPr>
+          <p:txBody>
+            <a:bodyPr lIns="0" rIns="0" tIns="0" bIns="0" anchorCtr="1" anchor="ctr" wrap="none"/>
+            <a:lstStyle/>
+            <a:p>
+              <a:pPr algn="l" marL="0" marR="0" indent="0">
+                <a:lnSpc>
+                  <a:spcPts val="1000"/>
+                </a:lnSpc>
+                <a:spcBef>
+                  <a:spcPts val="0"/>
+                </a:spcBef>
+                <a:spcAft>
+                  <a:spcPts val="0"/>
+                </a:spcAft>
+              </a:pPr>
+              <a:r>
+                <a:rPr sz="1000">
+                  <a:solidFill>
+                    <a:srgbClr val="000000">
+                      <a:alpha val="100000"/>
+                    </a:srgbClr>
+                  </a:solidFill>
+                  <a:latin typeface="Aptos"/>
+                  <a:cs typeface="Aptos"/>
+                </a:rPr>
+                <a:t>SftO₂</a:t>
+              </a:r>
+            </a:p>
+          </p:txBody>
+        </p:sp>
+        <p:sp>
+          <p:nvSpPr>
+            <p:cNvPr id="44" name="rc44"/>
+            <p:cNvSpPr/>
+            <p:nvPr/>
+          </p:nvSpPr>
+          <p:spPr>
+            <a:xfrm>
+              <a:off x="8361908" y="2936250"/>
+              <a:ext cx="1093350" cy="828041"/>
+            </a:xfrm>
+            <a:prstGeom prst="rect">
+              <a:avLst/>
+            </a:prstGeom>
+          </p:spPr>
+          <p:txBody>
+            <a:bodyPr/>
+            <a:lstStyle/>
+            <a:p/>
+          </p:txBody>
+        </p:sp>
+        <p:sp>
+          <p:nvSpPr>
+            <p:cNvPr id="45" name="tx45"/>
+            <p:cNvSpPr/>
+            <p:nvPr/>
+          </p:nvSpPr>
+          <p:spPr>
+            <a:xfrm>
+              <a:off x="8425171" y="2987886"/>
+              <a:ext cx="966824" cy="106784"/>
+            </a:xfrm>
+            <a:prstGeom prst="rect">
+              <a:avLst/>
+            </a:prstGeom>
+            <a:noFill/>
+          </p:spPr>
+          <p:txBody>
+            <a:bodyPr lIns="0" rIns="0" tIns="0" bIns="0" anchorCtr="1" anchor="ctr" wrap="none"/>
+            <a:lstStyle/>
+            <a:p>
+              <a:pPr algn="l" marL="0" marR="0" indent="0">
+                <a:lnSpc>
+                  <a:spcPts val="1000"/>
+                </a:lnSpc>
+                <a:spcBef>
+                  <a:spcPts val="0"/>
+                </a:spcBef>
+                <a:spcAft>
+                  <a:spcPts val="0"/>
+                </a:spcAft>
+              </a:pPr>
+              <a:r>
+                <a:rPr sz="1000" b="1">
+                  <a:solidFill>
+                    <a:srgbClr val="000000">
+                      <a:alpha val="100000"/>
+                    </a:srgbClr>
+                  </a:solidFill>
+                  <a:latin typeface="Aptos"/>
+                  <a:cs typeface="Aptos"/>
+                </a:rPr>
+                <a:t>Bootstrap 95%CI</a:t>
+              </a:r>
+            </a:p>
+          </p:txBody>
+        </p:sp>
+        <p:sp>
+          <p:nvSpPr>
+            <p:cNvPr id="46" name="rc46"/>
+            <p:cNvSpPr/>
+            <p:nvPr/>
+          </p:nvSpPr>
+          <p:spPr>
+            <a:xfrm>
+              <a:off x="8425171" y="3169622"/>
+              <a:ext cx="177135" cy="177135"/>
+            </a:xfrm>
+            <a:prstGeom prst="rect">
+              <a:avLst/>
+            </a:prstGeom>
+          </p:spPr>
+          <p:txBody>
+            <a:bodyPr/>
+            <a:lstStyle/>
+            <a:p/>
+          </p:txBody>
+        </p:sp>
+        <p:sp>
+          <p:nvSpPr>
+            <p:cNvPr id="47" name="rc47"/>
+            <p:cNvSpPr/>
+            <p:nvPr/>
+          </p:nvSpPr>
+          <p:spPr>
+            <a:xfrm>
+              <a:off x="8441371" y="3185822"/>
+              <a:ext cx="144735" cy="144735"/>
+            </a:xfrm>
+            <a:prstGeom prst="rect">
+              <a:avLst/>
+            </a:prstGeom>
+            <a:solidFill>
+              <a:srgbClr val="4F86C6">
+                <a:alpha val="100000"/>
+              </a:srgbClr>
+            </a:solidFill>
+            <a:ln w="24391" cap="flat">
+              <a:solidFill>
+                <a:srgbClr val="FFFFFF">
+                  <a:alpha val="100000"/>
+                </a:srgbClr>
+              </a:solidFill>
+              <a:prstDash val="solid"/>
+              <a:miter/>
+            </a:ln>
+          </p:spPr>
+          <p:txBody>
+            <a:bodyPr/>
+            <a:lstStyle/>
+            <a:p/>
+          </p:txBody>
+        </p:sp>
+        <p:sp>
+          <p:nvSpPr>
+            <p:cNvPr id="48" name="rc48"/>
+            <p:cNvSpPr/>
+            <p:nvPr/>
+          </p:nvSpPr>
+          <p:spPr>
+            <a:xfrm>
+              <a:off x="8425171" y="3346758"/>
+              <a:ext cx="177135" cy="177135"/>
+            </a:xfrm>
+            <a:prstGeom prst="rect">
+              <a:avLst/>
+            </a:prstGeom>
+          </p:spPr>
+          <p:txBody>
+            <a:bodyPr/>
+            <a:lstStyle/>
+            <a:p/>
+          </p:txBody>
+        </p:sp>
+        <p:sp>
+          <p:nvSpPr>
+            <p:cNvPr id="49" name="rc49"/>
+            <p:cNvSpPr/>
+            <p:nvPr/>
+          </p:nvSpPr>
+          <p:spPr>
+            <a:xfrm>
+              <a:off x="8425171" y="3523894"/>
+              <a:ext cx="177135" cy="177135"/>
+            </a:xfrm>
+            <a:prstGeom prst="rect">
+              <a:avLst/>
+            </a:prstGeom>
+          </p:spPr>
+          <p:txBody>
+            <a:bodyPr/>
+            <a:lstStyle/>
+            <a:p/>
+          </p:txBody>
+        </p:sp>
+        <p:sp>
+          <p:nvSpPr>
+            <p:cNvPr id="50" name="tx50"/>
+            <p:cNvSpPr/>
+            <p:nvPr/>
+          </p:nvSpPr>
+          <p:spPr>
+            <a:xfrm>
+              <a:off x="8665569" y="3214224"/>
+              <a:ext cx="548865" cy="85700"/>
+            </a:xfrm>
+            <a:prstGeom prst="rect">
+              <a:avLst/>
+            </a:prstGeom>
+            <a:noFill/>
+          </p:spPr>
+          <p:txBody>
+            <a:bodyPr lIns="0" rIns="0" tIns="0" bIns="0" anchorCtr="1" anchor="ctr" wrap="none"/>
+            <a:lstStyle/>
+            <a:p>
+              <a:pPr algn="l" marL="0" marR="0" indent="0">
+                <a:lnSpc>
+                  <a:spcPts val="1000"/>
+                </a:lnSpc>
+                <a:spcBef>
+                  <a:spcPts val="0"/>
+                </a:spcBef>
+                <a:spcAft>
+                  <a:spcPts val="0"/>
+                </a:spcAft>
+              </a:pPr>
+              <a:r>
+                <a:rPr sz="1000">
+                  <a:solidFill>
+                    <a:srgbClr val="000000">
+                      <a:alpha val="100000"/>
+                    </a:srgbClr>
+                  </a:solidFill>
+                  <a:latin typeface="Aptos"/>
+                  <a:cs typeface="Aptos"/>
+                </a:rPr>
+                <a:t>95%CI &gt; 0</a:t>
+              </a:r>
+            </a:p>
+          </p:txBody>
+        </p:sp>
+        <p:sp>
+          <p:nvSpPr>
+            <p:cNvPr id="51" name="tx51"/>
+            <p:cNvSpPr/>
+            <p:nvPr/>
+          </p:nvSpPr>
+          <p:spPr>
+            <a:xfrm>
+              <a:off x="8665569" y="3391359"/>
+              <a:ext cx="540866" cy="85700"/>
+            </a:xfrm>
+            <a:prstGeom prst="rect">
+              <a:avLst/>
+            </a:prstGeom>
+            <a:noFill/>
+          </p:spPr>
+          <p:txBody>
+            <a:bodyPr lIns="0" rIns="0" tIns="0" bIns="0" anchorCtr="1" anchor="ctr" wrap="none"/>
+            <a:lstStyle/>
+            <a:p>
+              <a:pPr algn="l" marL="0" marR="0" indent="0">
+                <a:lnSpc>
+                  <a:spcPts val="1000"/>
+                </a:lnSpc>
+                <a:spcBef>
+                  <a:spcPts val="0"/>
+                </a:spcBef>
+                <a:spcAft>
+                  <a:spcPts val="0"/>
+                </a:spcAft>
+              </a:pPr>
+              <a:r>
+                <a:rPr sz="1000">
+                  <a:solidFill>
+                    <a:srgbClr val="000000">
+                      <a:alpha val="100000"/>
+                    </a:srgbClr>
+                  </a:solidFill>
+                  <a:latin typeface="Aptos"/>
+                  <a:cs typeface="Aptos"/>
+                </a:rPr>
+                <a:t>95%CI ∋ 0</a:t>
+              </a:r>
+            </a:p>
+          </p:txBody>
+        </p:sp>
+        <p:sp>
+          <p:nvSpPr>
+            <p:cNvPr id="52" name="tx52"/>
+            <p:cNvSpPr/>
+            <p:nvPr/>
+          </p:nvSpPr>
+          <p:spPr>
+            <a:xfrm>
+              <a:off x="8665569" y="3568495"/>
+              <a:ext cx="548865" cy="85700"/>
+            </a:xfrm>
+            <a:prstGeom prst="rect">
+              <a:avLst/>
+            </a:prstGeom>
+            <a:noFill/>
+          </p:spPr>
+          <p:txBody>
+            <a:bodyPr lIns="0" rIns="0" tIns="0" bIns="0" anchorCtr="1" anchor="ctr" wrap="none"/>
+            <a:lstStyle/>
+            <a:p>
+              <a:pPr algn="l" marL="0" marR="0" indent="0">
+                <a:lnSpc>
+                  <a:spcPts val="1000"/>
+                </a:lnSpc>
+                <a:spcBef>
+                  <a:spcPts val="0"/>
+                </a:spcBef>
+                <a:spcAft>
+                  <a:spcPts val="0"/>
+                </a:spcAft>
+              </a:pPr>
+              <a:r>
+                <a:rPr sz="1000">
+                  <a:solidFill>
+                    <a:srgbClr val="000000">
+                      <a:alpha val="100000"/>
+                    </a:srgbClr>
+                  </a:solidFill>
+                  <a:latin typeface="Aptos"/>
+                  <a:cs typeface="Aptos"/>
+                </a:rPr>
+                <a:t>95%CI &lt; 0</a:t>
+              </a:r>
+            </a:p>
+          </p:txBody>
+        </p:sp>
+      </p:grpSp>
+    </p:spTree>
+  </p:cSld>
+  <p:clrMapOvr>
+    <a:masterClrMapping/>
+  </p:clrMapOvr>
+</p:sld>
+</file>
+
 <file path=ppt/tags/tag1.xml><?xml version="1.0" encoding="utf-8"?>
 <p:tagLst xmlns:a="http://schemas.openxmlformats.org/drawingml/2006/main" xmlns:r="http://schemas.openxmlformats.org/officeDocument/2006/relationships" xmlns:p="http://schemas.openxmlformats.org/presentationml/2006/main">
   <p:tag name="_AMO_UNIQUEIDENTIFIER" val="Empty"/>

</xml_diff>